<commit_message>
Update Verdigris model and deck with founder inputs
Product mix by funder (bridging £650k, development £1.25m at 30%),
analyst pay under £55k, and a salary benchmarks sheet showing industry
ranges beside the figures used. Deck figures re-synced to the model.

Co-Authored-By: Claude Fable 5.1 <noreply@anthropic.com>
Claude-Session: https://claude.ai/code/session_01WiYieSwuhSHZ2QAH5RV2m7
</commit_message>
<xml_diff>
--- a/verdigris-deliverables/Verdigris_Pitch_Deck.pptx
+++ b/verdigris-deliverables/Verdigris_Pitch_Deck.pptx
@@ -502,10 +502,10 @@
                   <c:v>37</c:v>
                 </c:pt>
                 <c:pt idx="1">
-                  <c:v>4.23</c:v>
+                  <c:v>4.14</c:v>
                 </c:pt>
                 <c:pt idx="2">
-                  <c:v>0.71</c:v>
+                  <c:v>0.68</c:v>
                 </c:pt>
               </c:numCache>
             </c:numRef>
@@ -585,10 +585,10 @@
                   <c:v>8</c:v>
                 </c:pt>
                 <c:pt idx="1">
-                  <c:v>1.05</c:v>
+                  <c:v>1.01</c:v>
                 </c:pt>
                 <c:pt idx="2">
-                  <c:v>3.9</c:v>
+                  <c:v>3.82</c:v>
                 </c:pt>
               </c:numCache>
             </c:numRef>
@@ -1293,10 +1293,10 @@
                   <c:v>0.7</c:v>
                 </c:pt>
                 <c:pt idx="1">
-                  <c:v>2.5</c:v>
+                  <c:v>2.4</c:v>
                 </c:pt>
                 <c:pt idx="2">
-                  <c:v>6</c:v>
+                  <c:v>5.9</c:v>
                 </c:pt>
               </c:numCache>
             </c:numRef>
@@ -1399,13 +1399,13 @@
                 <c:formatCode>General</c:formatCode>
                 <c:ptCount val="3"/>
                 <c:pt idx="0">
-                  <c:v>3.9</c:v>
+                  <c:v>3.8</c:v>
                 </c:pt>
                 <c:pt idx="1">
-                  <c:v>8.4</c:v>
+                  <c:v>8.2</c:v>
                 </c:pt>
                 <c:pt idx="2">
-                  <c:v>17.4</c:v>
+                  <c:v>17</c:v>
                 </c:pt>
               </c:numCache>
             </c:numRef>
@@ -2751,7 +2751,7 @@
           <a:p>
             <a:r>
               <a:rPr lang="en-US" dirty="0"/>
-              <a:t>Eight people: two founders, two senior underwriters who review and decide, one ops, one compliance, one BDM, one engineer. AI cost is £16 per case with a 10x safety factor, plus £50 of data searches.</a:t>
+              <a:t>Eight people: two founders, two senior underwriters who review and decide, one ops, one compliance, one BDM, one engineer. AI cost is £16 per case with a 10x safety factor, plus £50 of data searches. Traditional profit £0.68m, AI-native £3.82m on £4.8m net revenue.</a:t>
             </a:r>
             <a:endParaRPr lang="en-US" dirty="0"/>
           </a:p>
@@ -4080,7 +4080,7 @@
                 <a:ea typeface="Calibri" pitchFamily="34" charset="-122"/>
                 <a:cs typeface="Calibri" pitchFamily="34" charset="-120"/>
               </a:rPr>
-              <a:t>Per-case pricing to small and mid-size lenders at £250, against ~£700 of in-house cost per assessed case.</a:t>
+              <a:t>Per-case pricing to small and mid-size lenders at £250, against ~£600 of in-house cost per assessed case.</a:t>
             </a:r>
             <a:endParaRPr lang="en-US" sz="1000" dirty="0"/>
           </a:p>
@@ -4252,7 +4252,7 @@
                 <a:ea typeface="Calibri" pitchFamily="34" charset="-122"/>
                 <a:cs typeface="Calibri" pitchFamily="34" charset="-120"/>
               </a:rPr>
-              <a:t>A £150m book on the Verdigris cost base makes £3.9m a year, not £0.7m.</a:t>
+              <a:t>A £150m book on the Verdigris cost base makes £3.8m a year, not £0.7m.</a:t>
             </a:r>
             <a:endParaRPr lang="en-US" sz="1000" dirty="0"/>
           </a:p>
@@ -5578,7 +5578,7 @@
                 <a:ea typeface="Calibri" pitchFamily="34" charset="-122"/>
                 <a:cs typeface="Calibri" pitchFamily="34" charset="-120"/>
               </a:rPr>
-              <a:t>a domain founder who has done the job by hand, a market where cost is the only lever left, and a model that makes £3.9m where the incumbent makes £0.7m.</a:t>
+              <a:t>a domain founder who has done the job by hand, a market where cost is the only lever left, and a model that makes £3.8m where the incumbent makes £0.7m.</a:t>
             </a:r>
             <a:endParaRPr lang="en-US" sz="1100" dirty="0"/>
           </a:p>
@@ -5945,7 +5945,7 @@
                           <a:ea typeface="Calibri" pitchFamily="34" charset="-122"/>
                           <a:cs typeface="Calibri" pitchFamily="34" charset="-120"/>
                         </a:rPr>
-                        <a:t>Loan book / average loan / term</a:t>
+                        <a:t>Loan book / blended loan / term</a:t>
                       </a:r>
                       <a:endParaRPr lang="en-US" sz="900" dirty="0">
                         <a:latin typeface="Calibri" charset="0"/>
@@ -6010,7 +6010,7 @@
                           <a:ea typeface="Calibri" pitchFamily="34" charset="-122"/>
                           <a:cs typeface="Calibri" pitchFamily="34" charset="-120"/>
                         </a:rPr>
-                        <a:t>£150m / £650k / 12 mo</a:t>
+                        <a:t>£150m / £830k / 12 mo</a:t>
                       </a:r>
                       <a:endParaRPr lang="en-US" sz="900" dirty="0">
                         <a:latin typeface="Calibri" charset="0"/>
@@ -6075,7 +6075,7 @@
                           <a:ea typeface="Calibri" pitchFamily="34" charset="-122"/>
                           <a:cs typeface="Calibri" pitchFamily="34" charset="-120"/>
                         </a:rPr>
-                        <a:t>Founder pipeline data (median ≈ £440k, up to £1.6m); BDLA avg £540k</a:t>
+                        <a:t>Founder: bridging £500–800k (institutional partner), development £1–1.5m (bank partner), 30% dev</a:t>
                       </a:r>
                       <a:endParaRPr lang="en-US" sz="900" dirty="0">
                         <a:latin typeface="Calibri" charset="0"/>
@@ -6207,7 +6207,7 @@
                           <a:ea typeface="Calibri" pitchFamily="34" charset="-122"/>
                           <a:cs typeface="Calibri" pitchFamily="34" charset="-120"/>
                         </a:rPr>
-                        <a:t>231 / 924</a:t>
+                        <a:t>181 / 724</a:t>
                       </a:r>
                       <a:endParaRPr lang="en-US" sz="900" dirty="0">
                         <a:latin typeface="Calibri" charset="0"/>
@@ -7257,7 +7257,7 @@
                           <a:ea typeface="Calibri" pitchFamily="34" charset="-122"/>
                           <a:cs typeface="Calibri" pitchFamily="34" charset="-120"/>
                         </a:rPr>
-                        <a:t>Job ads and salary guides; NI 15%, pension 5%, 8% other on-costs</a:t>
+                        <a:t>Founder: analysts under £55k; other roles from job ads and guides; NI 15%, pension 5%, 8% other</a:t>
                       </a:r>
                       <a:endParaRPr lang="en-US" sz="900" dirty="0">
                         <a:latin typeface="Calibri" charset="0"/>
@@ -9166,7 +9166,7 @@
                 <a:ea typeface="Calibri" pitchFamily="34" charset="-122"/>
                 <a:cs typeface="Calibri" pitchFamily="34" charset="-120"/>
               </a:rPr>
-              <a:t>Figures from the Verdigris economics model — a £150m book, 231 loans a year, identical pricing and funding on both sides.</a:t>
+              <a:t>Figures from the Verdigris economics model — a £150m book, 181 loans a year, identical pricing and funding on both sides.</a:t>
             </a:r>
             <a:endParaRPr lang="en-US" sz="950" dirty="0"/>
           </a:p>
@@ -9992,7 +9992,7 @@
                           <a:ea typeface="Calibri" pitchFamily="34" charset="-122"/>
                           <a:cs typeface="Calibri" pitchFamily="34" charset="-120"/>
                         </a:rPr>
-                        <a:t>£2.1m</a:t>
+                        <a:t>£1.9m</a:t>
                       </a:r>
                       <a:endParaRPr lang="en-US" sz="1000" dirty="0">
                         <a:latin typeface="Calibri" charset="0"/>
@@ -10189,7 +10189,7 @@
                           <a:ea typeface="Calibri" pitchFamily="34" charset="-122"/>
                           <a:cs typeface="Calibri" pitchFamily="34" charset="-120"/>
                         </a:rPr>
-                        <a:t>(£0.9m)</a:t>
+                        <a:t>(£0.8m)</a:t>
                       </a:r>
                       <a:endParaRPr lang="en-US" sz="1000" dirty="0">
                         <a:latin typeface="Calibri" charset="0"/>
@@ -10389,7 +10389,7 @@
                           <a:ea typeface="Calibri" pitchFamily="34" charset="-122"/>
                           <a:cs typeface="Calibri" pitchFamily="34" charset="-120"/>
                         </a:rPr>
-                        <a:t>£4.9m</a:t>
+                        <a:t>£4.8m</a:t>
                       </a:r>
                       <a:endParaRPr lang="en-US" sz="1000" dirty="0">
                         <a:latin typeface="Calibri" charset="0"/>
@@ -10592,7 +10592,7 @@
                           <a:ea typeface="Calibri" pitchFamily="34" charset="-122"/>
                           <a:cs typeface="Calibri" pitchFamily="34" charset="-120"/>
                         </a:rPr>
-                        <a:t>(£3.7m)</a:t>
+                        <a:t>(£3.6m)</a:t>
                       </a:r>
                       <a:endParaRPr lang="en-US" sz="1000" dirty="0">
                         <a:latin typeface="Calibri" charset="0"/>
@@ -11057,7 +11057,7 @@
                           <a:ea typeface="Calibri" pitchFamily="34" charset="-122"/>
                           <a:cs typeface="Calibri" pitchFamily="34" charset="-120"/>
                         </a:rPr>
-                        <a:t>14% margin. £18,300 to originate each loan.</a:t>
+                        <a:t>14% margin. £22,900 to originate each loan.</a:t>
                       </a:r>
                       <a:endParaRPr lang="en-US" sz="1000" dirty="0">
                         <a:latin typeface="Calibri" charset="0"/>
@@ -11350,7 +11350,7 @@
                 <a:ea typeface="Cambria" pitchFamily="34" charset="-122"/>
                 <a:cs typeface="Cambria" pitchFamily="34" charset="-120"/>
               </a:rPr>
-              <a:t>4.0×</a:t>
+              <a:t>4.1×</a:t>
             </a:r>
             <a:endParaRPr lang="en-US" sz="3600" dirty="0"/>
           </a:p>
@@ -11428,7 +11428,7 @@
                 <a:ea typeface="Cambria" pitchFamily="34" charset="-122"/>
                 <a:cs typeface="Cambria" pitchFamily="34" charset="-120"/>
               </a:rPr>
-              <a:t>£4,500</a:t>
+              <a:t>£5,600</a:t>
             </a:r>
             <a:endParaRPr lang="en-US" sz="3600" dirty="0"/>
           </a:p>
@@ -11467,7 +11467,7 @@
                 <a:ea typeface="Calibri" pitchFamily="34" charset="-122"/>
                 <a:cs typeface="Calibri" pitchFamily="34" charset="-120"/>
               </a:rPr>
-              <a:t>to originate each loan, versus £18,300</a:t>
+              <a:t>to originate each loan, versus £22,900</a:t>
             </a:r>
             <a:endParaRPr lang="en-US" sz="1100" dirty="0"/>
           </a:p>

</xml_diff>